<commit_message>
docs: finalize TourPlanit challenge seven submission
</commit_message>
<xml_diff>
--- a/submission-package/2026-08-12/2026_웹앱구현_TourPlanit_기능설명서_작성본_v1.0_2026-08-12.pptx
+++ b/submission-package/2026-08-12/2026_웹앱구현_TourPlanit_기능설명서_작성본_v1.0_2026-08-12.pptx
@@ -2,21 +2,21 @@
 <file path=ppt/presentation.xml><?xml version="1.0" encoding="utf-8"?>
 <p:presentation xmlns:p="http://schemas.openxmlformats.org/presentationml/2006/main">
   <p:sldMasterIdLst>
-    <p:sldMasterId xmlns:r="http://schemas.openxmlformats.org/officeDocument/2006/relationships" id="2147483648" r:id="R5968d6073c0140f3"/>
+    <p:sldMasterId xmlns:r="http://schemas.openxmlformats.org/officeDocument/2006/relationships" id="2147483648" r:id="R14abe3ca789248f8"/>
   </p:sldMasterIdLst>
   <p:notesMasterIdLst>
-    <p:notesMasterId xmlns:r="http://schemas.openxmlformats.org/officeDocument/2006/relationships" r:id="R49e317e868e3470a"/>
+    <p:notesMasterId xmlns:r="http://schemas.openxmlformats.org/officeDocument/2006/relationships" r:id="R8eaa8763e3ee4f58"/>
   </p:notesMasterIdLst>
   <p:sldIdLst>
-    <p:sldId xmlns:r="http://schemas.openxmlformats.org/officeDocument/2006/relationships" id="256" r:id="R70eb6d54f84a4b20"/>
-    <p:sldId xmlns:r="http://schemas.openxmlformats.org/officeDocument/2006/relationships" id="257" r:id="R574436a46ee94645"/>
-    <p:sldId xmlns:r="http://schemas.openxmlformats.org/officeDocument/2006/relationships" id="258" r:id="R77c7f763857340f9"/>
-    <p:sldId xmlns:r="http://schemas.openxmlformats.org/officeDocument/2006/relationships" id="259" r:id="R40807ca5c6874320"/>
-    <p:sldId xmlns:r="http://schemas.openxmlformats.org/officeDocument/2006/relationships" id="260" r:id="Rfe12b2cd5ad44512"/>
-    <p:sldId xmlns:r="http://schemas.openxmlformats.org/officeDocument/2006/relationships" id="261" r:id="R1c5769f450d24504"/>
-    <p:sldId xmlns:r="http://schemas.openxmlformats.org/officeDocument/2006/relationships" id="262" r:id="Rfb4746133d464d31"/>
-    <p:sldId xmlns:r="http://schemas.openxmlformats.org/officeDocument/2006/relationships" id="263" r:id="R1800f514e7e34ad9"/>
-    <p:sldId xmlns:r="http://schemas.openxmlformats.org/officeDocument/2006/relationships" id="264" r:id="R22e838e1f9374f4f"/>
+    <p:sldId xmlns:r="http://schemas.openxmlformats.org/officeDocument/2006/relationships" id="256" r:id="R65cb59f5090e4cd3"/>
+    <p:sldId xmlns:r="http://schemas.openxmlformats.org/officeDocument/2006/relationships" id="257" r:id="Rf44f7da7b5234c39"/>
+    <p:sldId xmlns:r="http://schemas.openxmlformats.org/officeDocument/2006/relationships" id="258" r:id="R28f5e0b47072416d"/>
+    <p:sldId xmlns:r="http://schemas.openxmlformats.org/officeDocument/2006/relationships" id="259" r:id="R2cdfeb5686e4487b"/>
+    <p:sldId xmlns:r="http://schemas.openxmlformats.org/officeDocument/2006/relationships" id="260" r:id="Rde7d9cb1f20b4d68"/>
+    <p:sldId xmlns:r="http://schemas.openxmlformats.org/officeDocument/2006/relationships" id="261" r:id="R97094d8f39ff46b7"/>
+    <p:sldId xmlns:r="http://schemas.openxmlformats.org/officeDocument/2006/relationships" id="262" r:id="R36f6c4b928ae474c"/>
+    <p:sldId xmlns:r="http://schemas.openxmlformats.org/officeDocument/2006/relationships" id="263" r:id="Rd207ceddaf6b44f2"/>
+    <p:sldId xmlns:r="http://schemas.openxmlformats.org/officeDocument/2006/relationships" id="264" r:id="Rde1ac7c325f9468d"/>
   </p:sldIdLst>
   <p:sldSz cx="12192000" cy="6858000"/>
   <p:notesSz cx="6858000" cy="9144000"/>
@@ -471,6 +471,11 @@
           </a:p>
           <a:p xmlns:a="http://schemas.openxmlformats.org/drawingml/2006/main">
             <a:r>
+              <a:t>Official challenge list: https://www.hallym.ac.kr/bbs/hlsw/335/231332/download.do</a:t>
+            </a:r>
+          </a:p>
+          <a:p xmlns:a="http://schemas.openxmlformats.org/drawingml/2006/main">
+            <a:r>
               <a:t>Production service: https://tourplanit.netlify.app</a:t>
             </a:r>
           </a:p>
@@ -552,6 +557,11 @@
           <a:p xmlns:a="http://schemas.openxmlformats.org/drawingml/2006/main">
             <a:r>
               <a:t>Official notice: https://lowly-polyanthus-1fb.notion.site/2026-3a75dce406e38034a9a8d058a1b55596</a:t>
+            </a:r>
+          </a:p>
+          <a:p xmlns:a="http://schemas.openxmlformats.org/drawingml/2006/main">
+            <a:r>
+              <a:t>Official challenge list: https://www.hallym.ac.kr/bbs/hlsw/335/231332/download.do</a:t>
             </a:r>
           </a:p>
           <a:p xmlns:a="http://schemas.openxmlformats.org/drawingml/2006/main">
@@ -641,6 +651,11 @@
           </a:p>
           <a:p xmlns:a="http://schemas.openxmlformats.org/drawingml/2006/main">
             <a:r>
+              <a:t>Official challenge list: https://www.hallym.ac.kr/bbs/hlsw/335/231332/download.do</a:t>
+            </a:r>
+          </a:p>
+          <a:p xmlns:a="http://schemas.openxmlformats.org/drawingml/2006/main">
+            <a:r>
               <a:t>Production service: https://tourplanit.netlify.app</a:t>
             </a:r>
           </a:p>
@@ -722,6 +737,11 @@
           <a:p xmlns:a="http://schemas.openxmlformats.org/drawingml/2006/main">
             <a:r>
               <a:t>Official notice: https://lowly-polyanthus-1fb.notion.site/2026-3a75dce406e38034a9a8d058a1b55596</a:t>
+            </a:r>
+          </a:p>
+          <a:p xmlns:a="http://schemas.openxmlformats.org/drawingml/2006/main">
+            <a:r>
+              <a:t>Official challenge list: https://www.hallym.ac.kr/bbs/hlsw/335/231332/download.do</a:t>
             </a:r>
           </a:p>
           <a:p xmlns:a="http://schemas.openxmlformats.org/drawingml/2006/main">
@@ -811,6 +831,11 @@
           </a:p>
           <a:p xmlns:a="http://schemas.openxmlformats.org/drawingml/2006/main">
             <a:r>
+              <a:t>Official challenge list: https://www.hallym.ac.kr/bbs/hlsw/335/231332/download.do</a:t>
+            </a:r>
+          </a:p>
+          <a:p xmlns:a="http://schemas.openxmlformats.org/drawingml/2006/main">
+            <a:r>
               <a:t>Production service: https://tourplanit.netlify.app</a:t>
             </a:r>
           </a:p>
@@ -892,6 +917,11 @@
           <a:p xmlns:a="http://schemas.openxmlformats.org/drawingml/2006/main">
             <a:r>
               <a:t>Official notice: https://lowly-polyanthus-1fb.notion.site/2026-3a75dce406e38034a9a8d058a1b55596</a:t>
+            </a:r>
+          </a:p>
+          <a:p xmlns:a="http://schemas.openxmlformats.org/drawingml/2006/main">
+            <a:r>
+              <a:t>Official challenge list: https://www.hallym.ac.kr/bbs/hlsw/335/231332/download.do</a:t>
             </a:r>
           </a:p>
           <a:p xmlns:a="http://schemas.openxmlformats.org/drawingml/2006/main">
@@ -981,6 +1011,11 @@
           </a:p>
           <a:p xmlns:a="http://schemas.openxmlformats.org/drawingml/2006/main">
             <a:r>
+              <a:t>Official challenge list: https://www.hallym.ac.kr/bbs/hlsw/335/231332/download.do</a:t>
+            </a:r>
+          </a:p>
+          <a:p xmlns:a="http://schemas.openxmlformats.org/drawingml/2006/main">
+            <a:r>
               <a:t>Production service: https://tourplanit.netlify.app</a:t>
             </a:r>
           </a:p>
@@ -1062,6 +1097,11 @@
           <a:p xmlns:a="http://schemas.openxmlformats.org/drawingml/2006/main">
             <a:r>
               <a:t>Official notice: https://lowly-polyanthus-1fb.notion.site/2026-3a75dce406e38034a9a8d058a1b55596</a:t>
+            </a:r>
+          </a:p>
+          <a:p xmlns:a="http://schemas.openxmlformats.org/drawingml/2006/main">
+            <a:r>
+              <a:t>Official challenge list: https://www.hallym.ac.kr/bbs/hlsw/335/231332/download.do</a:t>
             </a:r>
           </a:p>
           <a:p xmlns:a="http://schemas.openxmlformats.org/drawingml/2006/main">
@@ -1151,6 +1191,11 @@
           </a:p>
           <a:p xmlns:a="http://schemas.openxmlformats.org/drawingml/2006/main">
             <a:r>
+              <a:t>Official challenge list: https://www.hallym.ac.kr/bbs/hlsw/335/231332/download.do</a:t>
+            </a:r>
+          </a:p>
+          <a:p xmlns:a="http://schemas.openxmlformats.org/drawingml/2006/main">
+            <a:r>
               <a:t>Production service: https://tourplanit.netlify.app</a:t>
             </a:r>
           </a:p>
@@ -1202,7 +1247,7 @@
           <p:nvPr/>
         </p:nvPicPr>
         <p:blipFill>
-          <a:blip xmlns:r="http://schemas.openxmlformats.org/officeDocument/2006/relationships" xmlns:a="http://schemas.openxmlformats.org/drawingml/2006/main" r:embed="R44419c27814042b6"/>
+          <a:blip xmlns:r="http://schemas.openxmlformats.org/officeDocument/2006/relationships" xmlns:a="http://schemas.openxmlformats.org/drawingml/2006/main" r:embed="R3a389fa0deb54e93"/>
           <a:stretch xmlns:a="http://schemas.openxmlformats.org/drawingml/2006/main">
             <a:fillRect l="0" t="0" r="0" b="0"/>
           </a:stretch>
@@ -1243,7 +1288,7 @@
           <p:nvPr/>
         </p:nvPicPr>
         <p:blipFill>
-          <a:blip xmlns:r="http://schemas.openxmlformats.org/officeDocument/2006/relationships" xmlns:a="http://schemas.openxmlformats.org/drawingml/2006/main" r:embed="R3b032196fceb4907"/>
+          <a:blip xmlns:r="http://schemas.openxmlformats.org/officeDocument/2006/relationships" xmlns:a="http://schemas.openxmlformats.org/drawingml/2006/main" r:embed="Ra7c9e34f30794cdf"/>
           <a:stretch xmlns:a="http://schemas.openxmlformats.org/drawingml/2006/main">
             <a:fillRect l="0" t="0" r="0" b="0"/>
           </a:stretch>
@@ -1284,7 +1329,7 @@
           <p:nvPr/>
         </p:nvPicPr>
         <p:blipFill>
-          <a:blip xmlns:r="http://schemas.openxmlformats.org/officeDocument/2006/relationships" xmlns:a="http://schemas.openxmlformats.org/drawingml/2006/main" r:embed="R9e98e68e475d48dd"/>
+          <a:blip xmlns:r="http://schemas.openxmlformats.org/officeDocument/2006/relationships" xmlns:a="http://schemas.openxmlformats.org/drawingml/2006/main" r:embed="R1a47ce93e3de453c"/>
           <a:stretch xmlns:a="http://schemas.openxmlformats.org/drawingml/2006/main">
             <a:fillRect l="0" t="0" r="0" b="0"/>
           </a:stretch>
@@ -1325,7 +1370,7 @@
           <p:nvPr/>
         </p:nvPicPr>
         <p:blipFill>
-          <a:blip xmlns:r="http://schemas.openxmlformats.org/officeDocument/2006/relationships" xmlns:a="http://schemas.openxmlformats.org/drawingml/2006/main" r:embed="Rbbfd8b4b6b2e442d"/>
+          <a:blip xmlns:r="http://schemas.openxmlformats.org/officeDocument/2006/relationships" xmlns:a="http://schemas.openxmlformats.org/drawingml/2006/main" r:embed="Rb345707d160f4e4b"/>
           <a:stretch xmlns:a="http://schemas.openxmlformats.org/drawingml/2006/main">
             <a:fillRect l="0" t="0" r="0" b="0"/>
           </a:stretch>
@@ -1366,7 +1411,7 @@
           <p:nvPr/>
         </p:nvPicPr>
         <p:blipFill>
-          <a:blip xmlns:r="http://schemas.openxmlformats.org/officeDocument/2006/relationships" xmlns:a="http://schemas.openxmlformats.org/drawingml/2006/main" r:embed="R886e2fced8734ffc"/>
+          <a:blip xmlns:r="http://schemas.openxmlformats.org/officeDocument/2006/relationships" xmlns:a="http://schemas.openxmlformats.org/drawingml/2006/main" r:embed="R1260b829c2e14ea4"/>
           <a:stretch xmlns:a="http://schemas.openxmlformats.org/drawingml/2006/main">
             <a:fillRect l="0" t="0" r="0" b="0"/>
           </a:stretch>
@@ -1407,7 +1452,7 @@
           <p:nvPr/>
         </p:nvPicPr>
         <p:blipFill>
-          <a:blip xmlns:r="http://schemas.openxmlformats.org/officeDocument/2006/relationships" xmlns:a="http://schemas.openxmlformats.org/drawingml/2006/main" r:embed="Rf80a1b79db4e4dc9"/>
+          <a:blip xmlns:r="http://schemas.openxmlformats.org/officeDocument/2006/relationships" xmlns:a="http://schemas.openxmlformats.org/drawingml/2006/main" r:embed="Rfd09c5d5ba054f8c"/>
           <a:stretch xmlns:a="http://schemas.openxmlformats.org/drawingml/2006/main">
             <a:fillRect l="0" t="0" r="0" b="0"/>
           </a:stretch>
@@ -1448,7 +1493,7 @@
           <p:nvPr/>
         </p:nvPicPr>
         <p:blipFill>
-          <a:blip xmlns:r="http://schemas.openxmlformats.org/officeDocument/2006/relationships" xmlns:a="http://schemas.openxmlformats.org/drawingml/2006/main" r:embed="R8ec38b4d558d4c4a"/>
+          <a:blip xmlns:r="http://schemas.openxmlformats.org/officeDocument/2006/relationships" xmlns:a="http://schemas.openxmlformats.org/drawingml/2006/main" r:embed="Rbeb4010e027c42db"/>
           <a:stretch xmlns:a="http://schemas.openxmlformats.org/drawingml/2006/main">
             <a:fillRect l="0" t="0" r="0" b="0"/>
           </a:stretch>
@@ -1570,7 +1615,7 @@
           <p:nvPr/>
         </p:nvPicPr>
         <p:blipFill>
-          <a:blip xmlns:r="http://schemas.openxmlformats.org/officeDocument/2006/relationships" xmlns:a="http://schemas.openxmlformats.org/drawingml/2006/main" r:embed="R86dd933811564b44"/>
+          <a:blip xmlns:r="http://schemas.openxmlformats.org/officeDocument/2006/relationships" xmlns:a="http://schemas.openxmlformats.org/drawingml/2006/main" r:embed="R15d3e6119942418e"/>
           <a:stretch xmlns:a="http://schemas.openxmlformats.org/drawingml/2006/main">
             <a:fillRect l="0" t="0" r="0" b="0"/>
           </a:stretch>
@@ -1858,14 +1903,14 @@
   </p:cSld>
   <p:clrMap bg1="lt1" tx1="dk1" bg2="lt2" tx2="dk2" accent1="accent1" accent2="accent2" accent3="accent3" accent4="accent4" accent5="accent5" accent6="accent6" hlink="hlink" folHlink="folHlink"/>
   <p:sldLayoutIdLst>
-    <p:sldLayoutId xmlns:r="http://schemas.openxmlformats.org/officeDocument/2006/relationships" id="2147483649" r:id="Ra8c304fc02bf4c45"/>
-    <p:sldLayoutId xmlns:r="http://schemas.openxmlformats.org/officeDocument/2006/relationships" id="2147483650" r:id="Rab95048208774ad3"/>
-    <p:sldLayoutId xmlns:r="http://schemas.openxmlformats.org/officeDocument/2006/relationships" id="2147483651" r:id="Rd8748dac94104c35"/>
-    <p:sldLayoutId xmlns:r="http://schemas.openxmlformats.org/officeDocument/2006/relationships" id="2147483652" r:id="R2217f4b876a24d8b"/>
-    <p:sldLayoutId xmlns:r="http://schemas.openxmlformats.org/officeDocument/2006/relationships" id="2147483653" r:id="R7799e6991517425e"/>
-    <p:sldLayoutId xmlns:r="http://schemas.openxmlformats.org/officeDocument/2006/relationships" id="2147483654" r:id="R25fe1d6c59a74d74"/>
-    <p:sldLayoutId xmlns:r="http://schemas.openxmlformats.org/officeDocument/2006/relationships" id="2147483655" r:id="R59dd869bd1cb4eaf"/>
-    <p:sldLayoutId xmlns:r="http://schemas.openxmlformats.org/officeDocument/2006/relationships" id="2147483656" r:id="R594bdf38f76f4eef"/>
+    <p:sldLayoutId xmlns:r="http://schemas.openxmlformats.org/officeDocument/2006/relationships" id="2147483649" r:id="Rc860a5b76b93487d"/>
+    <p:sldLayoutId xmlns:r="http://schemas.openxmlformats.org/officeDocument/2006/relationships" id="2147483650" r:id="R4af4cc8199904cfe"/>
+    <p:sldLayoutId xmlns:r="http://schemas.openxmlformats.org/officeDocument/2006/relationships" id="2147483651" r:id="R4cd742121ed94d90"/>
+    <p:sldLayoutId xmlns:r="http://schemas.openxmlformats.org/officeDocument/2006/relationships" id="2147483652" r:id="R984e7c5dc25647e6"/>
+    <p:sldLayoutId xmlns:r="http://schemas.openxmlformats.org/officeDocument/2006/relationships" id="2147483653" r:id="Re6759a1e542a40eb"/>
+    <p:sldLayoutId xmlns:r="http://schemas.openxmlformats.org/officeDocument/2006/relationships" id="2147483654" r:id="R18dc94fce2ff4ec1"/>
+    <p:sldLayoutId xmlns:r="http://schemas.openxmlformats.org/officeDocument/2006/relationships" id="2147483655" r:id="Rdc1305c6dc72470b"/>
+    <p:sldLayoutId xmlns:r="http://schemas.openxmlformats.org/officeDocument/2006/relationships" id="2147483656" r:id="R80fd84ed19d84ea8"/>
   </p:sldLayoutIdLst>
   <p:txStyles>
     <p:titleStyle>
@@ -2508,15 +2553,15 @@
                         <a:buNone/>
                       </a:pPr>
                       <a:r>
-                        <a:rPr b="1">
-                          <a:solidFill>
-                            <a:srgbClr val="C62828"/>
+                        <a:rPr>
+                          <a:solidFill>
+                            <a:srgbClr val="111111"/>
                           </a:solidFill>
                           <a:latin typeface="맑은 고딕"/>
                           <a:ea typeface="맑은 고딕"/>
                           <a:cs typeface="맑은 고딕"/>
                         </a:rPr>
-                        <a:t>[사용자 확인 필요] 참가신청 팀명</a:t>
+                        <a:t>와플(Wapple)</a:t>
                       </a:r>
                       <a:endParaRPr sz="2400" b="0">
                         <a:solidFill>
@@ -2622,7 +2667,7 @@
                           <a:ea typeface="맑은 고딕"/>
                           <a:cs typeface="맑은 고딕"/>
                         </a:rPr>
-                        <a:t>TourPlanit (투어플래닛)</a:t>
+                        <a:t>투어플래닛 (TourPlanit)</a:t>
                       </a:r>
                       <a:endParaRPr sz="2400" b="0">
                         <a:solidFill>
@@ -2780,7 +2825,7 @@
                           <a:ea typeface="맑은 고딕"/>
                           <a:cs typeface="맑은 고딕"/>
                         </a:rPr>
-                        <a:t>TourPlanit(투어플래닛) - 관광데이터 기반 여행상품 기획 자동화</a:t>
+                        <a:t>투어플래닛 (TourPlanit) - 관광데이터 기반 여행상품 기획 자동화</a:t>
                       </a:r>
                       <a:endParaRPr sz="1800" b="0" baseline="0">
                         <a:solidFill>
@@ -2909,7 +2954,7 @@
                           <a:ea typeface="맑은 고딕"/>
                           <a:cs typeface="맑은 고딕"/>
                         </a:rPr>
-                        <a:t>로그인 없이 사용하는 반응형 웹 서비스</a:t>
+                        <a:t>웹 - 로그인 없이 사용하는 반응형 서비스</a:t>
                       </a:r>
                       <a:endParaRPr sz="1800" b="0">
                         <a:solidFill>
@@ -3057,7 +3102,7 @@
                           <a:ea typeface="맑은 고딕"/>
                           <a:cs typeface="맑은 고딕"/>
                         </a:rPr>
-                        <a:t>신규 관광상품을 기획·검토·홍보하는 여행사 상품기획자·OP 및 지자체 관광 실무자</a:t>
+                        <a:t>신규 테마 관광 상품을 신속하게 개발 및 홍보해야 하는 여행사 및 지자체 여행 실무자</a:t>
                       </a:r>
                     </a:p>
                   </a:txBody>
@@ -3315,15 +3360,15 @@
                         <a:buNone/>
                       </a:pPr>
                       <a:r>
-                        <a:rPr sz="1800" b="1">
-                          <a:solidFill>
-                            <a:srgbClr val="C62828"/>
+                        <a:rPr sz="1800" b="0">
+                          <a:solidFill>
+                            <a:srgbClr val="111111"/>
                           </a:solidFill>
                           <a:latin typeface="맑은 고딕"/>
                           <a:ea typeface="맑은 고딕"/>
                           <a:cs typeface="맑은 고딕"/>
                         </a:rPr>
-                        <a:t>[사용자 확인 필요] 과제 7 - 전통적 여행상품 개발의 프로세스 파편화·공급 지연 문제 (콘텐츠랩 신청 정보와 대조 후 확정)</a:t>
+                        <a:t>지정과제 7번 - 전통적 여행 상품 개발 방식의 프로세스 파편화 및 공급 지연에 따른 급변하는 관광 트렌드와 수요에 대한 적기 대응 실패</a:t>
                       </a:r>
                       <a:endParaRPr sz="1800" b="0" baseline="0">
                         <a:solidFill>
@@ -3749,7 +3794,7 @@
                           <a:ea typeface="맑은 고딕"/>
                           <a:cs typeface="맑은 고딕"/>
                         </a:rPr>
-                        <a:t>지역·기간·테마·타깃·예산을 한 번 입력하면 KTO 관광지 조회 → AI 기획안 → 일정 → 견적 → 카드뉴스·블로그·카카오 문구로 이어지도록 구현했다. 실제 API 성공 데이터에만 출처·API명·필드·관광지 목록을 표시하고, 실패·빈 결과는 기본 데이터와 재확인 상태로 분리한다. AI 결과는 자동 발행하지 않고 담당자가 검토·수정·공유한다.</a:t>
+                        <a:t>공식 서비스 주제인 ‘상품 기획서 작성부터 다채널 마케팅 콘텐츠 제작까지의 과정을 자동화하는 실무 지원 서비스’를 구현한다. 지역·기간·테마·타깃·예산 입력 → KTO 관광지 조회 → AI 기획안 → 일정·견적 → 카드뉴스·블로그·카카오 문구로 연결한다. 실제 API 성공 데이터에만 출처·API명·필드·관광지 목록을 표시하며 AI 결과는 담당자가 검토·수정한다.</a:t>
                       </a:r>
                     </a:p>
                   </a:txBody>
@@ -3897,7 +3942,7 @@
                           <a:ea typeface="맑은 고딕"/>
                           <a:cs typeface="맑은 고딕"/>
                         </a:rPr>
-                        <a:t>#여행상품기획  #데이터기반  #관광수요  #관광지분석  #다채널홍보</a:t>
+                        <a:t>#여행 상품 기획  #데이터 기반  #관광 수요  #관광지 분석</a:t>
                       </a:r>
                     </a:p>
                   </a:txBody>
@@ -4231,7 +4276,7 @@
                           <a:ea typeface="맑은 고딕"/>
                           <a:cs typeface="맑은 고딕"/>
                         </a:rPr>
-                        <a:t>#여행상품기획</a:t>
+                        <a:t>#여행 상품 기획</a:t>
                       </a:r>
                       <a:endParaRPr sz="1800" b="0" baseline="0">
                         <a:solidFill>
@@ -4267,7 +4312,7 @@
                           <a:ea typeface="맑은 고딕"/>
                           <a:cs typeface="맑은 고딕"/>
                         </a:rPr>
-                        <a:t>#데이터기반</a:t>
+                        <a:t>#데이터 기반</a:t>
                       </a:r>
                       <a:endParaRPr sz="1800" b="0" baseline="0">
                         <a:solidFill>
@@ -4303,7 +4348,7 @@
                           <a:ea typeface="맑은 고딕"/>
                           <a:cs typeface="맑은 고딕"/>
                         </a:rPr>
-                        <a:t>#관광수요</a:t>
+                        <a:t>#관광 수요</a:t>
                       </a:r>
                       <a:endParaRPr b="0" i="1">
                         <a:solidFill>
@@ -4336,7 +4381,7 @@
                           <a:ea typeface="맑은 고딕"/>
                           <a:cs typeface="맑은 고딕"/>
                         </a:rPr>
-                        <a:t>#관광지분석</a:t>
+                        <a:t>#관광지 분석</a:t>
                       </a:r>
                       <a:endParaRPr b="0" i="1">
                         <a:solidFill>
@@ -4344,6 +4389,47 @@
                         </a:solidFill>
                       </a:endParaRPr>
                     </a:p>
+                  </a:txBody>
+                  <a:tcPr marL="91440" marR="91440" marT="45720" marB="45720" anchor="ctr">
+                    <a:lnL w="12700" cmpd="sng">
+                      <a:solidFill>
+                        <a:schemeClr val="bg1">
+                          <a:lumMod val="85000"/>
+                        </a:schemeClr>
+                      </a:solidFill>
+                      <a:prstDash val="solid"/>
+                    </a:lnL>
+                    <a:lnR w="12700" cmpd="sng">
+                      <a:solidFill>
+                        <a:schemeClr val="bg1">
+                          <a:lumMod val="85000"/>
+                        </a:schemeClr>
+                      </a:solidFill>
+                      <a:prstDash val="solid"/>
+                    </a:lnR>
+                    <a:lnT w="12700" cmpd="sng">
+                      <a:solidFill>
+                        <a:schemeClr val="bg1">
+                          <a:lumMod val="85000"/>
+                        </a:schemeClr>
+                      </a:solidFill>
+                      <a:prstDash val="solid"/>
+                    </a:lnT>
+                    <a:lnB w="12700" cmpd="sng">
+                      <a:solidFill>
+                        <a:schemeClr val="bg1">
+                          <a:lumMod val="85000"/>
+                        </a:schemeClr>
+                      </a:solidFill>
+                      <a:prstDash val="solid"/>
+                    </a:lnB>
+                    <a:noFill/>
+                  </a:tcPr>
+                </a:tc>
+                <a:tc>
+                  <a:txBody>
+                    <a:bodyPr/>
+                    <a:lstStyle/>
                     <a:p>
                       <a:pPr marL="0" marR="0" lvl="0" indent="0" algn="ctr" defTabSz="914400">
                         <a:lnSpc>
@@ -4361,7 +4447,7 @@
                         <a:buNone/>
                       </a:pPr>
                       <a:r>
-                        <a:rPr b="0" i="1">
+                        <a:rPr sz="1800" b="0">
                           <a:solidFill>
                             <a:srgbClr val="111111"/>
                           </a:solidFill>
@@ -4369,55 +4455,17 @@
                           <a:ea typeface="맑은 고딕"/>
                           <a:cs typeface="맑은 고딕"/>
                         </a:rPr>
-                        <a:t>#다채널홍보</a:t>
-                      </a:r>
-                      <a:endParaRPr b="0" i="1">
+                        <a:t>조건 입력·기획 요약</a:t>
+                      </a:r>
+                      <a:endParaRPr sz="1800" b="0" baseline="0">
                         <a:solidFill>
-                          <a:schemeClr val="tx1"/>
+                          <a:srgbClr val="FF0000"/>
                         </a:solidFill>
+                        <a:latin typeface="+mn-lt"/>
+                        <a:ea typeface="+mn-lt"/>
+                        <a:cs typeface="+mn-lt"/>
                       </a:endParaRPr>
                     </a:p>
-                  </a:txBody>
-                  <a:tcPr marL="91440" marR="91440" marT="45720" marB="45720" anchor="ctr">
-                    <a:lnL w="12700" cmpd="sng">
-                      <a:solidFill>
-                        <a:schemeClr val="bg1">
-                          <a:lumMod val="85000"/>
-                        </a:schemeClr>
-                      </a:solidFill>
-                      <a:prstDash val="solid"/>
-                    </a:lnL>
-                    <a:lnR w="12700" cmpd="sng">
-                      <a:solidFill>
-                        <a:schemeClr val="bg1">
-                          <a:lumMod val="85000"/>
-                        </a:schemeClr>
-                      </a:solidFill>
-                      <a:prstDash val="solid"/>
-                    </a:lnR>
-                    <a:lnT w="12700" cmpd="sng">
-                      <a:solidFill>
-                        <a:schemeClr val="bg1">
-                          <a:lumMod val="85000"/>
-                        </a:schemeClr>
-                      </a:solidFill>
-                      <a:prstDash val="solid"/>
-                    </a:lnT>
-                    <a:lnB w="12700" cmpd="sng">
-                      <a:solidFill>
-                        <a:schemeClr val="bg1">
-                          <a:lumMod val="85000"/>
-                        </a:schemeClr>
-                      </a:solidFill>
-                      <a:prstDash val="solid"/>
-                    </a:lnB>
-                    <a:noFill/>
-                  </a:tcPr>
-                </a:tc>
-                <a:tc>
-                  <a:txBody>
-                    <a:bodyPr/>
-                    <a:lstStyle/>
                     <a:p>
                       <a:pPr marL="0" marR="0" lvl="0" indent="0" algn="ctr" defTabSz="914400">
                         <a:lnSpc>
@@ -4443,7 +4491,7 @@
                           <a:ea typeface="맑은 고딕"/>
                           <a:cs typeface="맑은 고딕"/>
                         </a:rPr>
-                        <a:t>조건 입력·기획 요약</a:t>
+                        <a:t>관광 데이터 근거 패널</a:t>
                       </a:r>
                       <a:endParaRPr sz="1800" b="0" baseline="0">
                         <a:solidFill>
@@ -4471,7 +4519,7 @@
                         <a:buNone/>
                       </a:pPr>
                       <a:r>
-                        <a:rPr sz="1800" b="0">
+                        <a:rPr>
                           <a:solidFill>
                             <a:srgbClr val="111111"/>
                           </a:solidFill>
@@ -4479,11 +4527,11 @@
                           <a:ea typeface="맑은 고딕"/>
                           <a:cs typeface="맑은 고딕"/>
                         </a:rPr>
-                        <a:t>관광 데이터 근거 패널</a:t>
-                      </a:r>
-                      <a:endParaRPr sz="1800" b="0" baseline="0">
+                        <a:t>테마·타깃·기간 설정</a:t>
+                      </a:r>
+                      <a:endParaRPr sz="1800" b="0">
                         <a:solidFill>
-                          <a:srgbClr val="FF0000"/>
+                          <a:schemeClr val="tx1"/>
                         </a:solidFill>
                         <a:latin typeface="+mn-lt"/>
                         <a:ea typeface="+mn-lt"/>
@@ -4507,7 +4555,7 @@
                         <a:buNone/>
                       </a:pPr>
                       <a:r>
-                        <a:rPr>
+                        <a:rPr sz="1800" b="0">
                           <a:solidFill>
                             <a:srgbClr val="111111"/>
                           </a:solidFill>
@@ -4515,79 +4563,7 @@
                           <a:ea typeface="맑은 고딕"/>
                           <a:cs typeface="맑은 고딕"/>
                         </a:rPr>
-                        <a:t>테마·타깃·기간 설정</a:t>
-                      </a:r>
-                      <a:endParaRPr sz="1800" b="0">
-                        <a:solidFill>
-                          <a:schemeClr val="tx1"/>
-                        </a:solidFill>
-                        <a:latin typeface="+mn-lt"/>
-                        <a:ea typeface="+mn-lt"/>
-                        <a:cs typeface="+mn-lt"/>
-                      </a:endParaRPr>
-                    </a:p>
-                    <a:p>
-                      <a:pPr marL="0" marR="0" lvl="0" indent="0" algn="ctr" defTabSz="914400">
-                        <a:lnSpc>
-                          <a:spcPct val="100000"/>
-                        </a:lnSpc>
-                        <a:spcBef>
-                          <a:spcPts val="0"/>
-                        </a:spcBef>
-                        <a:spcAft>
-                          <a:spcPts val="0"/>
-                        </a:spcAft>
-                        <a:buClrTx/>
-                        <a:buSzTx/>
-                        <a:buFontTx/>
-                        <a:buNone/>
-                      </a:pPr>
-                      <a:r>
-                        <a:rPr sz="1800" b="0">
-                          <a:solidFill>
-                            <a:srgbClr val="111111"/>
-                          </a:solidFill>
-                          <a:latin typeface="맑은 고딕"/>
-                          <a:ea typeface="맑은 고딕"/>
-                          <a:cs typeface="맑은 고딕"/>
-                        </a:rPr>
                         <a:t>지역 관광지 후보 조회</a:t>
-                      </a:r>
-                      <a:endParaRPr sz="1800" b="0">
-                        <a:solidFill>
-                          <a:schemeClr val="tx1"/>
-                        </a:solidFill>
-                        <a:latin typeface="+mn-lt"/>
-                        <a:ea typeface="+mn-lt"/>
-                        <a:cs typeface="+mn-lt"/>
-                      </a:endParaRPr>
-                    </a:p>
-                    <a:p>
-                      <a:pPr marL="0" marR="0" lvl="0" indent="0" algn="ctr" defTabSz="914400">
-                        <a:lnSpc>
-                          <a:spcPct val="100000"/>
-                        </a:lnSpc>
-                        <a:spcBef>
-                          <a:spcPts val="0"/>
-                        </a:spcBef>
-                        <a:spcAft>
-                          <a:spcPts val="0"/>
-                        </a:spcAft>
-                        <a:buClrTx/>
-                        <a:buSzTx/>
-                        <a:buFontTx/>
-                        <a:buNone/>
-                      </a:pPr>
-                      <a:r>
-                        <a:rPr sz="1800" b="0">
-                          <a:solidFill>
-                            <a:srgbClr val="111111"/>
-                          </a:solidFill>
-                          <a:latin typeface="맑은 고딕"/>
-                          <a:ea typeface="맑은 고딕"/>
-                          <a:cs typeface="맑은 고딕"/>
-                        </a:rPr>
-                        <a:t>카드뉴스·블로그·카카오</a:t>
                       </a:r>
                       <a:endParaRPr sz="1800" b="0">
                         <a:solidFill>
@@ -4765,44 +4741,8 @@
                           <a:ea typeface="맑은 고딕"/>
                           <a:cs typeface="맑은 고딕"/>
                         </a:rPr>
-                        <a:t>areaBasedList2의 관광지명·주소·이미지·콘텐츠 ID·타입을 기획 후보로 활용한다.</a:t>
-                      </a:r>
-                    </a:p>
-                    <a:p>
-                      <a:pPr marL="0" marR="0" lvl="0" indent="0" algn="l" defTabSz="914400">
-                        <a:lnSpc>
-                          <a:spcPct val="100000"/>
-                        </a:lnSpc>
-                        <a:spcBef>
-                          <a:spcPts val="0"/>
-                        </a:spcBef>
-                        <a:spcAft>
-                          <a:spcPts val="0"/>
-                        </a:spcAft>
-                        <a:buClrTx/>
-                        <a:buSzTx/>
-                        <a:buFontTx/>
-                        <a:buNone/>
-                      </a:pPr>
-                      <a:r>
-                        <a:rPr sz="1800" b="0" i="1">
-                          <a:solidFill>
-                            <a:srgbClr val="111111"/>
-                          </a:solidFill>
-                          <a:latin typeface="맑은 고딕"/>
-                          <a:ea typeface="맑은 고딕"/>
-                          <a:cs typeface="맑은 고딕"/>
-                        </a:rPr>
-                        <a:t>동일 기획 결과를 4:5 카드뉴스, 블로그, 카카오 등 검토 가능한 홍보 초안으로 전환한다.</a:t>
-                      </a:r>
-                      <a:endParaRPr sz="1800" b="0" i="1" baseline="0">
-                        <a:solidFill>
-                          <a:srgbClr val="FF0000"/>
-                        </a:solidFill>
-                        <a:latin typeface="+mn-lt"/>
-                        <a:ea typeface="+mn-lt"/>
-                        <a:cs typeface="+mn-lt"/>
-                      </a:endParaRPr>
+                        <a:t>areaBasedList2의 관광지명·주소·이미지·콘텐츠 ID·타입을 기획 후보로 활용한다. 카드뉴스·블로그·카카오 문구는 공식 기능 예시의 ‘다채널 마케팅 홍보 카피 자동 생성’ 구현 결과로 별도 제공한다.</a:t>
+                      </a:r>
                     </a:p>
                   </a:txBody>
                   <a:tcPr marL="91440" marR="91440" marT="45720" marB="45720" anchor="ctr">
@@ -5990,7 +5930,7 @@
                           <a:ea typeface="맑은 고딕"/>
                           <a:cs typeface="맑은 고딕"/>
                         </a:rPr>
-                        <a:t>#데이터기반 #여행상품기획 #다채널홍보</a:t>
+                        <a:t>#여행 상품 기획 #데이터 기반 #관광 수요 #관광지 분석</a:t>
                       </a:r>
                       <a:endParaRPr b="0" i="1">
                         <a:solidFill>
@@ -6397,7 +6337,7 @@
           <p:nvPr/>
         </p:nvPicPr>
         <p:blipFill>
-          <a:blip xmlns:r="http://schemas.openxmlformats.org/officeDocument/2006/relationships" xmlns:a="http://schemas.openxmlformats.org/drawingml/2006/main" r:embed="Read3f4c7c1294ded"/>
+          <a:blip xmlns:r="http://schemas.openxmlformats.org/officeDocument/2006/relationships" xmlns:a="http://schemas.openxmlformats.org/drawingml/2006/main" r:embed="R7866c633c3074f60"/>
           <a:stretch xmlns:a="http://schemas.openxmlformats.org/drawingml/2006/main"/>
         </p:blipFill>
         <p:spPr>
@@ -6419,7 +6359,7 @@
           <p:nvPr/>
         </p:nvPicPr>
         <p:blipFill>
-          <a:blip xmlns:r="http://schemas.openxmlformats.org/officeDocument/2006/relationships" xmlns:a="http://schemas.openxmlformats.org/drawingml/2006/main" r:embed="R5e60fb8a5aae475b"/>
+          <a:blip xmlns:r="http://schemas.openxmlformats.org/officeDocument/2006/relationships" xmlns:a="http://schemas.openxmlformats.org/drawingml/2006/main" r:embed="R02f1b836a516480f"/>
           <a:stretch xmlns:a="http://schemas.openxmlformats.org/drawingml/2006/main"/>
         </p:blipFill>
         <p:spPr>
@@ -6441,7 +6381,7 @@
           <p:nvPr/>
         </p:nvPicPr>
         <p:blipFill>
-          <a:blip xmlns:r="http://schemas.openxmlformats.org/officeDocument/2006/relationships" xmlns:a="http://schemas.openxmlformats.org/drawingml/2006/main" r:embed="Re006b9075839472a"/>
+          <a:blip xmlns:r="http://schemas.openxmlformats.org/officeDocument/2006/relationships" xmlns:a="http://schemas.openxmlformats.org/drawingml/2006/main" r:embed="R0d123e1f94c848ff"/>
           <a:stretch xmlns:a="http://schemas.openxmlformats.org/drawingml/2006/main"/>
         </p:blipFill>
         <p:spPr>
@@ -6463,7 +6403,7 @@
           <p:nvPr/>
         </p:nvPicPr>
         <p:blipFill>
-          <a:blip xmlns:r="http://schemas.openxmlformats.org/officeDocument/2006/relationships" xmlns:a="http://schemas.openxmlformats.org/drawingml/2006/main" r:embed="R4e834510d73e4494"/>
+          <a:blip xmlns:r="http://schemas.openxmlformats.org/officeDocument/2006/relationships" xmlns:a="http://schemas.openxmlformats.org/drawingml/2006/main" r:embed="R6f77869b5d5a42d9"/>
           <a:stretch xmlns:a="http://schemas.openxmlformats.org/drawingml/2006/main"/>
         </p:blipFill>
         <p:spPr>
@@ -6881,7 +6821,7 @@
           <p:nvPr/>
         </p:nvPicPr>
         <p:blipFill>
-          <a:blip xmlns:r="http://schemas.openxmlformats.org/officeDocument/2006/relationships" xmlns:a="http://schemas.openxmlformats.org/drawingml/2006/main" r:embed="Rf388b4e40de2473b"/>
+          <a:blip xmlns:r="http://schemas.openxmlformats.org/officeDocument/2006/relationships" xmlns:a="http://schemas.openxmlformats.org/drawingml/2006/main" r:embed="R5ded60a7ef9d4422"/>
           <a:stretch xmlns:a="http://schemas.openxmlformats.org/drawingml/2006/main"/>
         </p:blipFill>
         <p:spPr>
@@ -6903,7 +6843,7 @@
           <p:nvPr/>
         </p:nvPicPr>
         <p:blipFill>
-          <a:blip xmlns:r="http://schemas.openxmlformats.org/officeDocument/2006/relationships" xmlns:a="http://schemas.openxmlformats.org/drawingml/2006/main" r:embed="Rac2780d53f524906"/>
+          <a:blip xmlns:r="http://schemas.openxmlformats.org/officeDocument/2006/relationships" xmlns:a="http://schemas.openxmlformats.org/drawingml/2006/main" r:embed="R15ec09ec4fe84952"/>
           <a:stretch xmlns:a="http://schemas.openxmlformats.org/drawingml/2006/main"/>
         </p:blipFill>
         <p:spPr>
@@ -6925,7 +6865,7 @@
           <p:nvPr/>
         </p:nvPicPr>
         <p:blipFill>
-          <a:blip xmlns:r="http://schemas.openxmlformats.org/officeDocument/2006/relationships" xmlns:a="http://schemas.openxmlformats.org/drawingml/2006/main" r:embed="Rd6ce8c974e4a42de"/>
+          <a:blip xmlns:r="http://schemas.openxmlformats.org/officeDocument/2006/relationships" xmlns:a="http://schemas.openxmlformats.org/drawingml/2006/main" r:embed="R68cb51f6ce4743ee"/>
           <a:stretch xmlns:a="http://schemas.openxmlformats.org/drawingml/2006/main"/>
         </p:blipFill>
         <p:spPr>
@@ -6947,7 +6887,7 @@
           <p:nvPr/>
         </p:nvPicPr>
         <p:blipFill>
-          <a:blip xmlns:r="http://schemas.openxmlformats.org/officeDocument/2006/relationships" xmlns:a="http://schemas.openxmlformats.org/drawingml/2006/main" r:embed="R8b7508714bca47d8"/>
+          <a:blip xmlns:r="http://schemas.openxmlformats.org/officeDocument/2006/relationships" xmlns:a="http://schemas.openxmlformats.org/drawingml/2006/main" r:embed="Rff77e1133fdc434d"/>
           <a:stretch xmlns:a="http://schemas.openxmlformats.org/drawingml/2006/main"/>
         </p:blipFill>
         <p:spPr>
@@ -6969,7 +6909,7 @@
           <p:nvPr/>
         </p:nvPicPr>
         <p:blipFill>
-          <a:blip xmlns:r="http://schemas.openxmlformats.org/officeDocument/2006/relationships" xmlns:a="http://schemas.openxmlformats.org/drawingml/2006/main" r:embed="Rddd00bc775fa4a2c"/>
+          <a:blip xmlns:r="http://schemas.openxmlformats.org/officeDocument/2006/relationships" xmlns:a="http://schemas.openxmlformats.org/drawingml/2006/main" r:embed="R17edcc3128ff416f"/>
           <a:stretch xmlns:a="http://schemas.openxmlformats.org/drawingml/2006/main"/>
         </p:blipFill>
         <p:spPr>

</xml_diff>